<commit_message>
fix(template): the specimen is baked again, and a test says when it is stale
Shapes stopped leaning on the theme's shape style some time ago, but the
specimen the project template ships with was never baked again: the band on
its cover still carried the reference, and LibreOffice drew a shadow under it
on every page copied from the cover.

The specimen is re-baked. A test now bakes the cover afresh and compares it
with the one shipped, so a change to the page writer that is not followed by
task specimen turns red.

Co-Authored-By: Claude Opus 5.5 <noreply@anthropic.com>
</commit_message>
<xml_diff>
--- a/src/pptx_agent_maker/templates/project/specimen.pptx
+++ b/src/pptx_agent_maker/templates/project/specimen.pptx
@@ -3145,20 +3145,6 @@
           </a:ln>
           <a:effectLst/>
         </p:spPr>
-        <p:style>
-          <a:lnRef idx="1">
-            <a:schemeClr val="accent1"/>
-          </a:lnRef>
-          <a:fillRef idx="3">
-            <a:schemeClr val="accent1"/>
-          </a:fillRef>
-          <a:effectRef idx="2">
-            <a:schemeClr val="accent1"/>
-          </a:effectRef>
-          <a:fontRef idx="minor">
-            <a:schemeClr val="lt1"/>
-          </a:fontRef>
-        </p:style>
         <p:txBody>
           <a:bodyPr rtlCol="0" anchor="ctr"/>
           <a:lstStyle/>

</xml_diff>

<commit_message>
fix(template): the specimen is baked again, and a test says when it is stale (#20)
Shapes stopped leaning on the theme's shape style some time ago, but the
specimen the project template ships with was never baked again: the band on
its cover still carried the reference, and LibreOffice drew a shadow under it
on every page copied from the cover.

The specimen is re-baked. A test now bakes the cover afresh and compares it
with the one shipped, so a change to the page writer that is not followed by
task specimen turns red.

Co-authored-by: synforger <synforger@users.noreply.github.com>
Co-authored-by: Claude Opus 5.5 <noreply@anthropic.com>
</commit_message>
<xml_diff>
--- a/src/pptx_agent_maker/templates/project/specimen.pptx
+++ b/src/pptx_agent_maker/templates/project/specimen.pptx
@@ -3145,20 +3145,6 @@
           </a:ln>
           <a:effectLst/>
         </p:spPr>
-        <p:style>
-          <a:lnRef idx="1">
-            <a:schemeClr val="accent1"/>
-          </a:lnRef>
-          <a:fillRef idx="3">
-            <a:schemeClr val="accent1"/>
-          </a:fillRef>
-          <a:effectRef idx="2">
-            <a:schemeClr val="accent1"/>
-          </a:effectRef>
-          <a:fontRef idx="minor">
-            <a:schemeClr val="lt1"/>
-          </a:fontRef>
-        </p:style>
         <p:txBody>
           <a:bodyPr rtlCol="0" anchor="ctr"/>
           <a:lstStyle/>

</xml_diff>